<commit_message>
Unify author name to Mhyiar Elmistere across report, slides, and code
</commit_message>
<xml_diff>
--- a/slides/TLS_Handshake_Presentation.pptx
+++ b/slides/TLS_Handshake_Presentation.pptx
@@ -4588,7 +4588,7 @@
                 </a:solidFill>
                 <a:latin typeface="Calibri"/>
               </a:rPr>
-              <a:t>Mihyar Al-Taher Al-Mustiri</a:t>
+              <a:t>Mhyiar Elmistere</a:t>
             </a:r>
           </a:p>
           <a:p>
@@ -6649,7 +6649,7 @@
                 </a:solidFill>
                 <a:latin typeface="Calibri"/>
               </a:rPr>
-              <a:t>Mihyar Al-Taher Al-Mustiri  |  github.com/Mhyiar98/tls-handshake-project</a:t>
+              <a:t>Mhyiar Elmistere  |  github.com/Mhyiar98/tls-handshake-project</a:t>
             </a:r>
           </a:p>
         </p:txBody>

</xml_diff>